<commit_message>
git commit -m "Update Communication Orale_JDA1_sujets ag\303\251s_30mai.pptx and Communication Orale_JDA1_sujets_enfant_30mai.pptx"
</commit_message>
<xml_diff>
--- a/Communication Orale_JDA1_sujets agés_30mai.pptx
+++ b/Communication Orale_JDA1_sujets agés_30mai.pptx
@@ -11211,16 +11211,284 @@
           </a:bodyPr>
           <a:lstStyle/>
           <a:p>
-            <a:pPr marL="0" lvl="0" indent="0" algn="l" rtl="0">
+            <a:pPr marL="0" marR="0" lvl="0" indent="0" algn="just" defTabSz="914400" rtl="0" eaLnBrk="1" fontAlgn="auto" latinLnBrk="0" hangingPunct="1">
+              <a:lnSpc>
+                <a:spcPct val="110000"/>
+              </a:lnSpc>
               <a:spcBef>
                 <a:spcPts val="0"/>
               </a:spcBef>
               <a:spcAft>
-                <a:spcPts val="0"/>
+                <a:spcPts val="400"/>
               </a:spcAft>
-              <a:buNone/>
+              <a:buClrTx/>
+              <a:buSzTx/>
+              <a:buFont typeface="Arial" panose="020B0604020202020204" pitchFamily="34" charset="0"/>
+              <a:buNone/>
+              <a:tabLst/>
+              <a:defRPr/>
             </a:pPr>
-            <a:endParaRPr dirty="0"/>
+            <a:r>
+              <a:rPr kumimoji="0" lang="fr-FR" sz="1200" b="1" i="0" u="none" strike="noStrike" kern="1200" cap="none" spc="0" normalizeH="0" baseline="0" noProof="0" dirty="0">
+                <a:ln>
+                  <a:noFill/>
+                </a:ln>
+                <a:solidFill>
+                  <a:srgbClr val="005B2C"/>
+                </a:solidFill>
+                <a:effectLst/>
+                <a:uLnTx/>
+                <a:uFillTx/>
+                <a:latin typeface="+mn-lt"/>
+                <a:ea typeface="+mn-ea"/>
+                <a:cs typeface="Arial" panose="020B0604020202020204" pitchFamily="34" charset="0"/>
+              </a:rPr>
+              <a:t>Introduction — </a:t>
+            </a:r>
+            <a:r>
+              <a:rPr kumimoji="0" lang="fr-FR" sz="1200" b="0" i="0" u="none" strike="noStrike" kern="1200" cap="none" spc="0" normalizeH="0" baseline="0" noProof="0" dirty="0">
+                <a:ln>
+                  <a:noFill/>
+                </a:ln>
+                <a:solidFill>
+                  <a:prstClr val="black"/>
+                </a:solidFill>
+                <a:effectLst/>
+                <a:uLnTx/>
+                <a:uFillTx/>
+                <a:latin typeface="+mn-lt"/>
+                <a:ea typeface="+mn-ea"/>
+                <a:cs typeface="Arial" panose="020B0604020202020204" pitchFamily="34" charset="0"/>
+              </a:rPr>
+              <a:t>Les dermatoses bulleuses du sujet âgé, rares mais potentiellement graves, restent peu documentées en Afrique sub-saharienne. Ce travail visait à en dresser le panorama clinique, étiologique et nosologique au CNHU-HKM de Cotonou.</a:t>
+            </a:r>
+          </a:p>
+          <a:p>
+            <a:pPr marL="0" marR="0" lvl="0" indent="0" algn="just" defTabSz="914400" rtl="0" eaLnBrk="1" fontAlgn="auto" latinLnBrk="0" hangingPunct="1">
+              <a:lnSpc>
+                <a:spcPct val="110000"/>
+              </a:lnSpc>
+              <a:spcBef>
+                <a:spcPts val="0"/>
+              </a:spcBef>
+              <a:spcAft>
+                <a:spcPts val="400"/>
+              </a:spcAft>
+              <a:buClrTx/>
+              <a:buSzTx/>
+              <a:buFont typeface="Arial" panose="020B0604020202020204" pitchFamily="34" charset="0"/>
+              <a:buNone/>
+              <a:tabLst/>
+              <a:defRPr/>
+            </a:pPr>
+            <a:r>
+              <a:rPr kumimoji="0" lang="fr-FR" sz="1200" b="1" i="0" u="none" strike="noStrike" kern="1200" cap="none" spc="0" normalizeH="0" baseline="0" noProof="0" dirty="0">
+                <a:ln>
+                  <a:noFill/>
+                </a:ln>
+                <a:solidFill>
+                  <a:srgbClr val="005B2C"/>
+                </a:solidFill>
+                <a:effectLst/>
+                <a:uLnTx/>
+                <a:uFillTx/>
+                <a:latin typeface="+mn-lt"/>
+                <a:ea typeface="+mn-ea"/>
+                <a:cs typeface="Arial" panose="020B0604020202020204" pitchFamily="34" charset="0"/>
+              </a:rPr>
+              <a:t>Méthodes — </a:t>
+            </a:r>
+            <a:r>
+              <a:rPr kumimoji="0" lang="fr-FR" sz="1200" b="0" i="0" u="none" strike="noStrike" kern="1200" cap="none" spc="0" normalizeH="0" baseline="0" noProof="0" dirty="0">
+                <a:ln>
+                  <a:noFill/>
+                </a:ln>
+                <a:solidFill>
+                  <a:prstClr val="black"/>
+                </a:solidFill>
+                <a:effectLst/>
+                <a:uLnTx/>
+                <a:uFillTx/>
+                <a:latin typeface="+mn-lt"/>
+                <a:ea typeface="+mn-ea"/>
+                <a:cs typeface="Arial" panose="020B0604020202020204" pitchFamily="34" charset="0"/>
+              </a:rPr>
+              <a:t>Étude transversale, rétrospective et descriptive, menée de janvier 2016 à mars 2026 à la Clinique Universitaire de Dermatologie-Vénérologie, à partir des registres de consultations (29 patients âgés de 60 ans et plus).</a:t>
+            </a:r>
+          </a:p>
+          <a:p>
+            <a:pPr marL="0" marR="0" lvl="0" indent="0" algn="just" defTabSz="914400" rtl="0" eaLnBrk="1" fontAlgn="auto" latinLnBrk="0" hangingPunct="1">
+              <a:lnSpc>
+                <a:spcPct val="110000"/>
+              </a:lnSpc>
+              <a:spcBef>
+                <a:spcPts val="0"/>
+              </a:spcBef>
+              <a:spcAft>
+                <a:spcPts val="400"/>
+              </a:spcAft>
+              <a:buClrTx/>
+              <a:buSzTx/>
+              <a:buFont typeface="Arial" panose="020B0604020202020204" pitchFamily="34" charset="0"/>
+              <a:buNone/>
+              <a:tabLst/>
+              <a:defRPr/>
+            </a:pPr>
+            <a:r>
+              <a:rPr kumimoji="0" lang="fr-FR" sz="1200" b="1" i="0" u="none" strike="noStrike" kern="1200" cap="none" spc="0" normalizeH="0" baseline="0" noProof="0" dirty="0">
+                <a:ln>
+                  <a:noFill/>
+                </a:ln>
+                <a:solidFill>
+                  <a:srgbClr val="005B2C"/>
+                </a:solidFill>
+                <a:effectLst/>
+                <a:uLnTx/>
+                <a:uFillTx/>
+                <a:latin typeface="+mn-lt"/>
+                <a:ea typeface="+mn-ea"/>
+                <a:cs typeface="Arial" panose="020B0604020202020204" pitchFamily="34" charset="0"/>
+              </a:rPr>
+              <a:t>Résultats — </a:t>
+            </a:r>
+            <a:r>
+              <a:rPr kumimoji="0" lang="fr-FR" sz="1200" b="0" i="0" u="none" strike="noStrike" kern="1200" cap="none" spc="0" normalizeH="0" baseline="0" noProof="0" dirty="0">
+                <a:ln>
+                  <a:noFill/>
+                </a:ln>
+                <a:solidFill>
+                  <a:prstClr val="black"/>
+                </a:solidFill>
+                <a:effectLst/>
+                <a:uLnTx/>
+                <a:uFillTx/>
+                <a:latin typeface="+mn-lt"/>
+                <a:ea typeface="+mn-ea"/>
+                <a:cs typeface="Arial" panose="020B0604020202020204" pitchFamily="34" charset="0"/>
+              </a:rPr>
+              <a:t>Prédominance féminine (58,6 % ; sex-ratio F/H = 1,42). Trois grandes étiologies ont été identifiées : auto-immunes (62,1 %), dominées par la pemphigoïde bulleuse ; toxidermies (31,0 %), avec une prise médicamenteuse retrouvée dans 88,9 % des cas et le cotrimoxazole comme première molécule incriminée ; causes infectieuses (6,9 %). Plus d’un quart des patients (27,6 %) présentaient une forme étendue (≥ 30 % de la surface corporelle).</a:t>
+            </a:r>
+          </a:p>
+          <a:p>
+            <a:pPr marL="0" marR="0" lvl="0" indent="0" algn="just" defTabSz="914400" rtl="0" eaLnBrk="1" fontAlgn="auto" latinLnBrk="0" hangingPunct="1">
+              <a:lnSpc>
+                <a:spcPct val="110000"/>
+              </a:lnSpc>
+              <a:spcBef>
+                <a:spcPts val="0"/>
+              </a:spcBef>
+              <a:spcAft>
+                <a:spcPts val="0"/>
+              </a:spcAft>
+              <a:buClrTx/>
+              <a:buSzTx/>
+              <a:buFont typeface="Arial" panose="020B0604020202020204" pitchFamily="34" charset="0"/>
+              <a:buNone/>
+              <a:tabLst/>
+              <a:defRPr/>
+            </a:pPr>
+            <a:r>
+              <a:rPr kumimoji="0" lang="fr-FR" sz="1200" b="1" i="0" u="none" strike="noStrike" kern="1200" cap="none" spc="0" normalizeH="0" baseline="0" noProof="0" dirty="0">
+                <a:ln>
+                  <a:noFill/>
+                </a:ln>
+                <a:solidFill>
+                  <a:srgbClr val="005B2C"/>
+                </a:solidFill>
+                <a:effectLst/>
+                <a:uLnTx/>
+                <a:uFillTx/>
+                <a:latin typeface="+mn-lt"/>
+                <a:ea typeface="+mn-ea"/>
+                <a:cs typeface="Arial" panose="020B0604020202020204" pitchFamily="34" charset="0"/>
+              </a:rPr>
+              <a:t>Discussion et perspectives — </a:t>
+            </a:r>
+            <a:r>
+              <a:rPr kumimoji="0" lang="fr-FR" sz="1200" b="0" i="0" u="none" strike="noStrike" kern="1200" cap="none" spc="0" normalizeH="0" baseline="0" noProof="0" dirty="0">
+                <a:ln>
+                  <a:noFill/>
+                </a:ln>
+                <a:solidFill>
+                  <a:prstClr val="black"/>
+                </a:solidFill>
+                <a:effectLst/>
+                <a:uLnTx/>
+                <a:uFillTx/>
+                <a:latin typeface="+mn-lt"/>
+                <a:ea typeface="+mn-ea"/>
+                <a:cs typeface="Arial" panose="020B0604020202020204" pitchFamily="34" charset="0"/>
+              </a:rPr>
+              <a:t>Ces données, concordantes avec la littérature ouest-africaine et internationale, confirment la place prépondérante des dermatoses auto-immunes et le rôle déterminant du médicament — en particulier du cotrimoxazole — dans la survenue des formes graves. Elles plaident pour un renforcement de la pharmacovigilance, un diagnostic précoce et un meilleur accès à l’</a:t>
+            </a:r>
+            <a:r>
+              <a:rPr kumimoji="0" lang="fr-FR" sz="1200" b="0" i="0" u="none" strike="noStrike" kern="1200" cap="none" spc="0" normalizeH="0" baseline="0" noProof="0" dirty="0" err="1">
+                <a:ln>
+                  <a:noFill/>
+                </a:ln>
+                <a:solidFill>
+                  <a:prstClr val="black"/>
+                </a:solidFill>
+                <a:effectLst/>
+                <a:uLnTx/>
+                <a:uFillTx/>
+                <a:latin typeface="+mn-lt"/>
+                <a:ea typeface="+mn-ea"/>
+                <a:cs typeface="Arial" panose="020B0604020202020204" pitchFamily="34" charset="0"/>
+              </a:rPr>
+              <a:t>immunopathologie</a:t>
+            </a:r>
+            <a:r>
+              <a:rPr kumimoji="0" lang="fr-FR" sz="1200" b="0" i="0" u="none" strike="noStrike" kern="1200" cap="none" spc="0" normalizeH="0" baseline="0" noProof="0" dirty="0">
+                <a:ln>
+                  <a:noFill/>
+                </a:ln>
+                <a:solidFill>
+                  <a:prstClr val="black"/>
+                </a:solidFill>
+                <a:effectLst/>
+                <a:uLnTx/>
+                <a:uFillTx/>
+                <a:latin typeface="+mn-lt"/>
+                <a:ea typeface="+mn-ea"/>
+                <a:cs typeface="Arial" panose="020B0604020202020204" pitchFamily="34" charset="0"/>
+              </a:rPr>
+              <a:t>. Une étude prospective et multicentrique permettrait de consolider ces données </a:t>
+            </a:r>
+            <a:r>
+              <a:rPr kumimoji="0" lang="fr-FR" sz="1200" b="0" i="0" u="none" strike="noStrike" kern="1200" cap="none" spc="0" normalizeH="0" baseline="0" noProof="0" dirty="0" err="1">
+                <a:ln>
+                  <a:noFill/>
+                </a:ln>
+                <a:solidFill>
+                  <a:prstClr val="black"/>
+                </a:solidFill>
+                <a:effectLst/>
+                <a:uLnTx/>
+                <a:uFillTx/>
+                <a:latin typeface="+mn-lt"/>
+                <a:ea typeface="+mn-ea"/>
+                <a:cs typeface="Arial" panose="020B0604020202020204" pitchFamily="34" charset="0"/>
+              </a:rPr>
+              <a:t>retrospectiveS</a:t>
+            </a:r>
+            <a:r>
+              <a:rPr kumimoji="0" lang="fr-FR" sz="1200" b="0" i="0" u="none" strike="noStrike" kern="1200" cap="none" spc="0" normalizeH="0" baseline="0" noProof="0" dirty="0">
+                <a:ln>
+                  <a:noFill/>
+                </a:ln>
+                <a:solidFill>
+                  <a:prstClr val="black"/>
+                </a:solidFill>
+                <a:effectLst/>
+                <a:uLnTx/>
+                <a:uFillTx/>
+                <a:latin typeface="+mn-lt"/>
+                <a:ea typeface="+mn-ea"/>
+                <a:cs typeface="Arial" panose="020B0604020202020204" pitchFamily="34" charset="0"/>
+              </a:rPr>
+              <a:t>.</a:t>
+            </a:r>
           </a:p>
         </p:txBody>
       </p:sp>
@@ -26822,8 +27090,8 @@
         </p:nvSpPr>
         <p:spPr>
           <a:xfrm>
-            <a:off x="1010077" y="788842"/>
-            <a:ext cx="10171839" cy="5760883"/>
+            <a:off x="1010076" y="933513"/>
+            <a:ext cx="10171839" cy="5162117"/>
           </a:xfrm>
           <a:prstGeom prst="roundRect">
             <a:avLst>
@@ -27010,230 +27278,470 @@
             </a:lvl9pPr>
           </a:lstStyle>
           <a:p>
-            <a:pPr marL="0" marR="0" lvl="0" indent="0" algn="just" defTabSz="914400" rtl="0" eaLnBrk="1" fontAlgn="auto" latinLnBrk="0" hangingPunct="1">
-              <a:lnSpc>
-                <a:spcPct val="110000"/>
-              </a:lnSpc>
+            <a:pPr marL="25400" lvl="0" indent="0" algn="l">
               <a:spcBef>
                 <a:spcPts val="0"/>
               </a:spcBef>
               <a:spcAft>
-                <a:spcPts val="400"/>
+                <a:spcPts val="200"/>
               </a:spcAft>
-              <a:buClrTx/>
-              <a:buSzTx/>
-              <a:buFont typeface="Arial" panose="020B0604020202020204" pitchFamily="34" charset="0"/>
-              <a:buNone/>
-              <a:tabLst/>
-              <a:defRPr/>
+              <a:buNone/>
             </a:pPr>
             <a:r>
-              <a:rPr kumimoji="0" lang="fr-FR" sz="1800" b="1" i="0" u="none" strike="noStrike" kern="1200" cap="none" spc="0" normalizeH="0" baseline="0" noProof="0">
-                <a:ln>
-                  <a:noFill/>
-                </a:ln>
+              <a:rPr lang="fr-FR" sz="1800" b="1" cap="all" dirty="0">
                 <a:solidFill>
-                  <a:srgbClr val="005B2C"/>
+                  <a:srgbClr val="C28300"/>
                 </a:solidFill>
-                <a:effectLst/>
-                <a:uLnTx/>
-                <a:uFillTx/>
-                <a:latin typeface="Calibri" panose="020F0502020204030204"/>
-                <a:ea typeface="+mn-ea"/>
-                <a:cs typeface="Arial" panose="020B0604020202020204" pitchFamily="34" charset="0"/>
+                <a:cs typeface="Arial" pitchFamily="34" charset="0"/>
               </a:rPr>
-              <a:t>Introduction — </a:t>
-            </a:r>
-            <a:r>
-              <a:rPr kumimoji="0" lang="fr-FR" sz="1800" b="0" i="0" u="none" strike="noStrike" kern="1200" cap="none" spc="0" normalizeH="0" baseline="0" noProof="0">
-                <a:ln>
-                  <a:noFill/>
-                </a:ln>
+              <a:t>▶ Synthèse de l'étude</a:t>
+            </a:r>
+          </a:p>
+          <a:p>
+            <a:pPr marL="285750" indent="-285750" algn="l">
+              <a:spcBef>
+                <a:spcPts val="0"/>
+              </a:spcBef>
+              <a:spcAft>
+                <a:spcPts val="150"/>
+              </a:spcAft>
+              <a:buNone/>
+            </a:pPr>
+            <a:r>
+              <a:rPr lang="fr-FR" sz="1600" dirty="0">
+                <a:cs typeface="Arial" pitchFamily="34" charset="0"/>
+              </a:rPr>
+              <a:t>•  Série hospitalière consacrée aux </a:t>
+            </a:r>
+            <a:r>
+              <a:rPr lang="fr-FR" sz="1600" b="1" dirty="0">
+                <a:cs typeface="Arial" pitchFamily="34" charset="0"/>
+              </a:rPr>
+              <a:t>dermatoses bulleuses du sujet âgé</a:t>
+            </a:r>
+            <a:r>
+              <a:rPr lang="fr-FR" sz="1600" dirty="0">
+                <a:cs typeface="Arial" pitchFamily="34" charset="0"/>
+              </a:rPr>
+              <a:t> : 29 patients de 60 ans et plus, CNHU-HKM de Cotonou, janvier 2016 – mars 2026</a:t>
+            </a:r>
+          </a:p>
+          <a:p>
+            <a:pPr marL="25400" lvl="0" indent="0" algn="l">
+              <a:spcBef>
+                <a:spcPts val="0"/>
+              </a:spcBef>
+              <a:spcAft>
+                <a:spcPts val="200"/>
+              </a:spcAft>
+              <a:buNone/>
+            </a:pPr>
+            <a:r>
+              <a:rPr lang="fr-FR" sz="1800" b="1" cap="all" dirty="0">
                 <a:solidFill>
-                  <a:prstClr val="black"/>
+                  <a:srgbClr val="C28300"/>
                 </a:solidFill>
-                <a:effectLst/>
-                <a:uLnTx/>
-                <a:uFillTx/>
-                <a:latin typeface="Calibri" panose="020F0502020204030204"/>
-                <a:ea typeface="+mn-ea"/>
-                <a:cs typeface="Arial" panose="020B0604020202020204" pitchFamily="34" charset="0"/>
+                <a:cs typeface="Arial" pitchFamily="34" charset="0"/>
               </a:rPr>
-              <a:t>Les dermatoses bulleuses du sujet âgé, rares mais potentiellement graves, restent peu documentées en Afrique sub-saharienne. Ce travail visait à en dresser le panorama clinique, étiologique et nosologique au CNHU-HKM de Cotonou.</a:t>
-            </a:r>
-          </a:p>
-          <a:p>
-            <a:pPr marL="0" marR="0" lvl="0" indent="0" algn="just" defTabSz="914400" rtl="0" eaLnBrk="1" fontAlgn="auto" latinLnBrk="0" hangingPunct="1">
-              <a:lnSpc>
-                <a:spcPct val="110000"/>
-              </a:lnSpc>
+              <a:t>▶ Principaux résultats</a:t>
+            </a:r>
+          </a:p>
+          <a:p>
+            <a:pPr marL="285750" indent="-285750" algn="l">
               <a:spcBef>
                 <a:spcPts val="0"/>
               </a:spcBef>
               <a:spcAft>
-                <a:spcPts val="400"/>
+                <a:spcPts val="100"/>
               </a:spcAft>
-              <a:buClrTx/>
-              <a:buSzTx/>
-              <a:buFont typeface="Arial" panose="020B0604020202020204" pitchFamily="34" charset="0"/>
-              <a:buNone/>
-              <a:tabLst/>
-              <a:defRPr/>
+              <a:buNone/>
             </a:pPr>
             <a:r>
-              <a:rPr kumimoji="0" lang="fr-FR" sz="1800" b="1" i="0" u="none" strike="noStrike" kern="1200" cap="none" spc="0" normalizeH="0" baseline="0" noProof="0">
-                <a:ln>
-                  <a:noFill/>
-                </a:ln>
+              <a:rPr lang="fr-FR" sz="1600" b="1" dirty="0">
+                <a:cs typeface="Arial" pitchFamily="34" charset="0"/>
+              </a:rPr>
+              <a:t>• Prédominance féminine</a:t>
+            </a:r>
+            <a:r>
+              <a:rPr lang="fr-FR" sz="1600" dirty="0">
+                <a:cs typeface="Arial" pitchFamily="34" charset="0"/>
+              </a:rPr>
+              <a:t> (58,6 % ; sex-ratio F/H = 1,42)</a:t>
+            </a:r>
+          </a:p>
+          <a:p>
+            <a:pPr marL="285750" indent="-285750" algn="l">
+              <a:spcBef>
+                <a:spcPts val="0"/>
+              </a:spcBef>
+              <a:spcAft>
+                <a:spcPts val="100"/>
+              </a:spcAft>
+              <a:buNone/>
+            </a:pPr>
+            <a:r>
+              <a:rPr lang="fr-FR" sz="1600" b="1" dirty="0">
+                <a:cs typeface="Arial" pitchFamily="34" charset="0"/>
+              </a:rPr>
+              <a:t>• Trois grandes étiologies identifiées :</a:t>
+            </a:r>
+          </a:p>
+          <a:p>
+            <a:pPr marL="571500" lvl="1" indent="-200025" algn="l">
+              <a:spcBef>
+                <a:spcPts val="0"/>
+              </a:spcBef>
+              <a:spcAft>
+                <a:spcPts val="50"/>
+              </a:spcAft>
+              <a:buNone/>
+            </a:pPr>
+            <a:r>
+              <a:rPr lang="fr-FR" sz="1600" dirty="0">
+                <a:cs typeface="Arial" pitchFamily="34" charset="0"/>
+              </a:rPr>
+              <a:t>	– Auto-immunes (</a:t>
+            </a:r>
+            <a:r>
+              <a:rPr lang="fr-FR" sz="1600" b="1" dirty="0">
+                <a:cs typeface="Arial" pitchFamily="34" charset="0"/>
+              </a:rPr>
+              <a:t>62,1 %</a:t>
+            </a:r>
+            <a:r>
+              <a:rPr lang="fr-FR" sz="1600" dirty="0">
+                <a:cs typeface="Arial" pitchFamily="34" charset="0"/>
+              </a:rPr>
+              <a:t>), dominées par la pemphigoïde bulleuse ;</a:t>
+            </a:r>
+          </a:p>
+          <a:p>
+            <a:pPr marL="571500" lvl="1" indent="-200025" algn="l">
+              <a:spcBef>
+                <a:spcPts val="0"/>
+              </a:spcBef>
+              <a:spcAft>
+                <a:spcPts val="50"/>
+              </a:spcAft>
+              <a:buNone/>
+            </a:pPr>
+            <a:r>
+              <a:rPr lang="fr-FR" sz="1600" dirty="0">
+                <a:cs typeface="Arial" pitchFamily="34" charset="0"/>
+              </a:rPr>
+              <a:t>	– Toxidermies (</a:t>
+            </a:r>
+            <a:r>
+              <a:rPr lang="fr-FR" sz="1600" b="1" dirty="0">
+                <a:cs typeface="Arial" pitchFamily="34" charset="0"/>
+              </a:rPr>
+              <a:t>31,0 %</a:t>
+            </a:r>
+            <a:r>
+              <a:rPr lang="fr-FR" sz="1600" dirty="0">
+                <a:cs typeface="Arial" pitchFamily="34" charset="0"/>
+              </a:rPr>
+              <a:t>), prise médicamenteuse retrouvée dans </a:t>
+            </a:r>
+            <a:r>
+              <a:rPr lang="fr-FR" sz="1600" b="1" dirty="0">
+                <a:cs typeface="Arial" pitchFamily="34" charset="0"/>
+              </a:rPr>
+              <a:t>88,9 %</a:t>
+            </a:r>
+            <a:r>
+              <a:rPr lang="fr-FR" sz="1600" dirty="0">
+                <a:cs typeface="Arial" pitchFamily="34" charset="0"/>
+              </a:rPr>
+              <a:t> des cas, </a:t>
+            </a:r>
+            <a:r>
+              <a:rPr lang="fr-FR" sz="1600" b="1" dirty="0">
+                <a:cs typeface="Arial" pitchFamily="34" charset="0"/>
+              </a:rPr>
+              <a:t>cotrimoxazole</a:t>
+            </a:r>
+            <a:r>
+              <a:rPr lang="fr-FR" sz="1600" dirty="0">
+                <a:cs typeface="Arial" pitchFamily="34" charset="0"/>
+              </a:rPr>
+              <a:t> en première ligne ;</a:t>
+            </a:r>
+          </a:p>
+          <a:p>
+            <a:pPr marL="571500" lvl="1" indent="-200025" algn="l">
+              <a:spcBef>
+                <a:spcPts val="0"/>
+              </a:spcBef>
+              <a:spcAft>
+                <a:spcPts val="50"/>
+              </a:spcAft>
+              <a:buNone/>
+            </a:pPr>
+            <a:r>
+              <a:rPr lang="fr-FR" sz="1600" dirty="0">
+                <a:cs typeface="Arial" pitchFamily="34" charset="0"/>
+              </a:rPr>
+              <a:t>	– Causes infectieuses (</a:t>
+            </a:r>
+            <a:r>
+              <a:rPr lang="fr-FR" sz="1600" b="1" dirty="0">
+                <a:cs typeface="Arial" pitchFamily="34" charset="0"/>
+              </a:rPr>
+              <a:t>6,9 %</a:t>
+            </a:r>
+            <a:r>
+              <a:rPr lang="fr-FR" sz="1600" dirty="0">
+                <a:cs typeface="Arial" pitchFamily="34" charset="0"/>
+              </a:rPr>
+              <a:t>)</a:t>
+            </a:r>
+          </a:p>
+          <a:p>
+            <a:pPr marL="285750" indent="-285750" algn="l">
+              <a:spcBef>
+                <a:spcPts val="0"/>
+              </a:spcBef>
+              <a:spcAft>
+                <a:spcPts val="150"/>
+              </a:spcAft>
+              <a:buNone/>
+            </a:pPr>
+            <a:r>
+              <a:rPr lang="fr-FR" sz="1600" dirty="0">
+                <a:cs typeface="Arial" pitchFamily="34" charset="0"/>
+              </a:rPr>
+              <a:t>• Plus d'un quart des patients (</a:t>
+            </a:r>
+            <a:r>
+              <a:rPr lang="fr-FR" sz="1600" b="1" dirty="0">
+                <a:cs typeface="Arial" pitchFamily="34" charset="0"/>
+              </a:rPr>
+              <a:t>27,6 %</a:t>
+            </a:r>
+            <a:r>
+              <a:rPr lang="fr-FR" sz="1600" dirty="0">
+                <a:cs typeface="Arial" pitchFamily="34" charset="0"/>
+              </a:rPr>
+              <a:t>) présentaient une </a:t>
+            </a:r>
+            <a:r>
+              <a:rPr lang="fr-FR" sz="1600" b="1" dirty="0">
+                <a:cs typeface="Arial" pitchFamily="34" charset="0"/>
+              </a:rPr>
+              <a:t>forme étendue</a:t>
+            </a:r>
+            <a:r>
+              <a:rPr lang="fr-FR" sz="1600" dirty="0">
+                <a:cs typeface="Arial" pitchFamily="34" charset="0"/>
+              </a:rPr>
+              <a:t> (≥ 30 % de la surface corporelle)</a:t>
+            </a:r>
+          </a:p>
+          <a:p>
+            <a:pPr marL="25400" lvl="0" indent="0" algn="l">
+              <a:spcBef>
+                <a:spcPts val="0"/>
+              </a:spcBef>
+              <a:spcAft>
+                <a:spcPts val="200"/>
+              </a:spcAft>
+              <a:buNone/>
+            </a:pPr>
+            <a:r>
+              <a:rPr lang="fr-FR" sz="1800" b="1" cap="all" dirty="0">
                 <a:solidFill>
-                  <a:srgbClr val="005B2C"/>
+                  <a:srgbClr val="C28300"/>
                 </a:solidFill>
-                <a:effectLst/>
-                <a:uLnTx/>
-                <a:uFillTx/>
-                <a:latin typeface="Calibri" panose="020F0502020204030204"/>
-                <a:ea typeface="+mn-ea"/>
-                <a:cs typeface="Arial" panose="020B0604020202020204" pitchFamily="34" charset="0"/>
+                <a:cs typeface="Arial" pitchFamily="34" charset="0"/>
               </a:rPr>
-              <a:t>Méthodes — </a:t>
-            </a:r>
-            <a:r>
-              <a:rPr kumimoji="0" lang="fr-FR" sz="1800" b="0" i="0" u="none" strike="noStrike" kern="1200" cap="none" spc="0" normalizeH="0" baseline="0" noProof="0">
-                <a:ln>
-                  <a:noFill/>
-                </a:ln>
+              <a:t>▶ Place de l'iatrogénie et concordance avec la littérature</a:t>
+            </a:r>
+          </a:p>
+          <a:p>
+            <a:pPr marL="285750" indent="-285750" algn="l">
+              <a:spcBef>
+                <a:spcPts val="0"/>
+              </a:spcBef>
+              <a:spcAft>
+                <a:spcPts val="100"/>
+              </a:spcAft>
+              <a:buNone/>
+            </a:pPr>
+            <a:r>
+              <a:rPr lang="fr-FR" sz="1600" dirty="0">
+                <a:cs typeface="Arial" pitchFamily="34" charset="0"/>
+              </a:rPr>
+              <a:t>• Données </a:t>
+            </a:r>
+            <a:r>
+              <a:rPr lang="fr-FR" sz="1600" b="1" dirty="0">
+                <a:cs typeface="Arial" pitchFamily="34" charset="0"/>
+              </a:rPr>
+              <a:t>concordantes avec la littérature ouest-africaine et internationale</a:t>
+            </a:r>
+          </a:p>
+          <a:p>
+            <a:pPr marL="285750" indent="-285750" algn="l">
+              <a:spcBef>
+                <a:spcPts val="0"/>
+              </a:spcBef>
+              <a:spcAft>
+                <a:spcPts val="100"/>
+              </a:spcAft>
+              <a:buNone/>
+            </a:pPr>
+            <a:r>
+              <a:rPr lang="fr-FR" sz="1600" dirty="0">
+                <a:cs typeface="Arial" pitchFamily="34" charset="0"/>
+              </a:rPr>
+              <a:t>• Confirmation de la </a:t>
+            </a:r>
+            <a:r>
+              <a:rPr lang="fr-FR" sz="1600" b="1" dirty="0">
+                <a:cs typeface="Arial" pitchFamily="34" charset="0"/>
+              </a:rPr>
+              <a:t>place prépondérante des dermatoses auto-immunes</a:t>
+            </a:r>
+            <a:r>
+              <a:rPr lang="fr-FR" sz="1600" dirty="0">
+                <a:cs typeface="Arial" pitchFamily="34" charset="0"/>
+              </a:rPr>
+              <a:t> et du </a:t>
+            </a:r>
+            <a:r>
+              <a:rPr lang="fr-FR" sz="1600" b="1" dirty="0">
+                <a:cs typeface="Arial" pitchFamily="34" charset="0"/>
+              </a:rPr>
+              <a:t>rôle déterminant du médicament</a:t>
+            </a:r>
+            <a:r>
+              <a:rPr lang="fr-FR" sz="1600" dirty="0">
+                <a:cs typeface="Arial" pitchFamily="34" charset="0"/>
+              </a:rPr>
+              <a:t> — en particulier du cotrimoxazole — dans la survenue des formes graves</a:t>
+            </a:r>
+          </a:p>
+          <a:p>
+            <a:pPr marL="25400" lvl="0" indent="0" algn="l">
+              <a:spcBef>
+                <a:spcPts val="0"/>
+              </a:spcBef>
+              <a:spcAft>
+                <a:spcPts val="200"/>
+              </a:spcAft>
+              <a:buNone/>
+            </a:pPr>
+            <a:r>
+              <a:rPr lang="fr-FR" sz="1800" b="1" cap="all" dirty="0">
                 <a:solidFill>
-                  <a:prstClr val="black"/>
+                  <a:srgbClr val="C28300"/>
                 </a:solidFill>
-                <a:effectLst/>
-                <a:uLnTx/>
-                <a:uFillTx/>
-                <a:latin typeface="Calibri" panose="020F0502020204030204"/>
-                <a:ea typeface="+mn-ea"/>
-                <a:cs typeface="Arial" panose="020B0604020202020204" pitchFamily="34" charset="0"/>
+                <a:cs typeface="Arial" pitchFamily="34" charset="0"/>
               </a:rPr>
-              <a:t>Étude transversale, rétrospective et descriptive, menée de janvier 2016 à mars 2026 à la Clinique Universitaire de Dermatologie-Vénérologie, à partir des registres de consultations (29 patients âgés de 60 ans et plus).</a:t>
-            </a:r>
-          </a:p>
-          <a:p>
-            <a:pPr marL="0" marR="0" lvl="0" indent="0" algn="just" defTabSz="914400" rtl="0" eaLnBrk="1" fontAlgn="auto" latinLnBrk="0" hangingPunct="1">
-              <a:lnSpc>
-                <a:spcPct val="110000"/>
-              </a:lnSpc>
+              <a:t>▶ Implications et perspectives</a:t>
+            </a:r>
+          </a:p>
+          <a:p>
+            <a:pPr marL="285750" indent="-285750" algn="l">
               <a:spcBef>
                 <a:spcPts val="0"/>
               </a:spcBef>
               <a:spcAft>
-                <a:spcPts val="400"/>
+                <a:spcPts val="100"/>
               </a:spcAft>
-              <a:buClrTx/>
-              <a:buSzTx/>
-              <a:buFont typeface="Arial" panose="020B0604020202020204" pitchFamily="34" charset="0"/>
-              <a:buNone/>
-              <a:tabLst/>
-              <a:defRPr/>
+              <a:buNone/>
             </a:pPr>
             <a:r>
-              <a:rPr kumimoji="0" lang="fr-FR" sz="1800" b="1" i="0" u="none" strike="noStrike" kern="1200" cap="none" spc="0" normalizeH="0" baseline="0" noProof="0">
-                <a:ln>
-                  <a:noFill/>
-                </a:ln>
-                <a:solidFill>
-                  <a:srgbClr val="005B2C"/>
-                </a:solidFill>
-                <a:effectLst/>
-                <a:uLnTx/>
-                <a:uFillTx/>
-                <a:latin typeface="Calibri" panose="020F0502020204030204"/>
-                <a:ea typeface="+mn-ea"/>
-                <a:cs typeface="Arial" panose="020B0604020202020204" pitchFamily="34" charset="0"/>
+              <a:rPr lang="fr-FR" sz="1600" dirty="0">
+                <a:cs typeface="Arial" pitchFamily="34" charset="0"/>
               </a:rPr>
-              <a:t>Résultats — </a:t>
-            </a:r>
-            <a:r>
-              <a:rPr kumimoji="0" lang="fr-FR" sz="1800" b="0" i="0" u="none" strike="noStrike" kern="1200" cap="none" spc="0" normalizeH="0" baseline="0" noProof="0">
-                <a:ln>
-                  <a:noFill/>
-                </a:ln>
-                <a:solidFill>
-                  <a:prstClr val="black"/>
-                </a:solidFill>
-                <a:effectLst/>
-                <a:uLnTx/>
-                <a:uFillTx/>
-                <a:latin typeface="Calibri" panose="020F0502020204030204"/>
-                <a:ea typeface="+mn-ea"/>
-                <a:cs typeface="Arial" panose="020B0604020202020204" pitchFamily="34" charset="0"/>
+              <a:t>• Renforcement de la </a:t>
+            </a:r>
+            <a:r>
+              <a:rPr lang="fr-FR" sz="1600" b="1" dirty="0">
+                <a:cs typeface="Arial" pitchFamily="34" charset="0"/>
               </a:rPr>
-              <a:t>Prédominance féminine (58,6 % ; sex-ratio F/H = 1,42). Trois grandes étiologies ont été identifiées : auto-immunes (62,1 %), dominées par la pemphigoïde bulleuse ; toxidermies (31,0 %), avec une prise médicamenteuse retrouvée dans 88,9 % des cas et le cotrimoxazole comme première molécule incriminée ; causes infectieuses (6,9 %). Plus d’un quart des patients (27,6 %) présentaient une forme étendue (≥ 30 % de la surface corporelle).</a:t>
-            </a:r>
-          </a:p>
-          <a:p>
-            <a:pPr marL="0" marR="0" lvl="0" indent="0" algn="just" defTabSz="914400" rtl="0" eaLnBrk="1" fontAlgn="auto" latinLnBrk="0" hangingPunct="1">
-              <a:lnSpc>
-                <a:spcPct val="110000"/>
-              </a:lnSpc>
+              <a:t>pharmacovigilance</a:t>
+            </a:r>
+          </a:p>
+          <a:p>
+            <a:pPr marL="285750" indent="-285750" algn="l">
               <a:spcBef>
                 <a:spcPts val="0"/>
               </a:spcBef>
               <a:spcAft>
-                <a:spcPts val="0"/>
+                <a:spcPts val="100"/>
               </a:spcAft>
-              <a:buClrTx/>
-              <a:buSzTx/>
-              <a:buFont typeface="Arial" panose="020B0604020202020204" pitchFamily="34" charset="0"/>
-              <a:buNone/>
-              <a:tabLst/>
-              <a:defRPr/>
+              <a:buNone/>
             </a:pPr>
             <a:r>
-              <a:rPr kumimoji="0" lang="fr-FR" sz="1800" b="1" i="0" u="none" strike="noStrike" kern="1200" cap="none" spc="0" normalizeH="0" baseline="0" noProof="0">
-                <a:ln>
-                  <a:noFill/>
-                </a:ln>
-                <a:solidFill>
-                  <a:srgbClr val="005B2C"/>
-                </a:solidFill>
-                <a:effectLst/>
-                <a:uLnTx/>
-                <a:uFillTx/>
-                <a:latin typeface="Calibri" panose="020F0502020204030204"/>
-                <a:ea typeface="+mn-ea"/>
-                <a:cs typeface="Arial" panose="020B0604020202020204" pitchFamily="34" charset="0"/>
+              <a:rPr lang="fr-FR" sz="1600" b="1" dirty="0">
+                <a:cs typeface="Arial" pitchFamily="34" charset="0"/>
               </a:rPr>
-              <a:t>Discussion et perspectives — </a:t>
-            </a:r>
-            <a:r>
-              <a:rPr kumimoji="0" lang="fr-FR" sz="1800" b="0" i="0" u="none" strike="noStrike" kern="1200" cap="none" spc="0" normalizeH="0" baseline="0" noProof="0">
-                <a:ln>
-                  <a:noFill/>
-                </a:ln>
-                <a:solidFill>
-                  <a:prstClr val="black"/>
-                </a:solidFill>
-                <a:effectLst/>
-                <a:uLnTx/>
-                <a:uFillTx/>
-                <a:latin typeface="Calibri" panose="020F0502020204030204"/>
-                <a:ea typeface="+mn-ea"/>
-                <a:cs typeface="Arial" panose="020B0604020202020204" pitchFamily="34" charset="0"/>
+              <a:t>• Diagnostic précoce</a:t>
+            </a:r>
+            <a:r>
+              <a:rPr lang="fr-FR" sz="1600" dirty="0">
+                <a:cs typeface="Arial" pitchFamily="34" charset="0"/>
               </a:rPr>
-              <a:t>Ces données, concordantes avec la littérature ouest-africaine et internationale, confirment la place prépondérante des dermatoses auto-immunes et le rôle déterminant du médicament — en particulier du cotrimoxazole — dans la survenue des formes graves. Elles plaident pour un renforcement de la pharmacovigilance, un diagnostic précoce et un meilleur accès à l’immunopathologie. Une étude prospective et multicentrique permettrait de consolider ces premières données béninoises.</a:t>
-            </a:r>
-            <a:endParaRPr kumimoji="0" lang="fr-FR" sz="1800" b="0" i="0" u="none" strike="noStrike" kern="1200" cap="none" spc="0" normalizeH="0" baseline="0" noProof="0" dirty="0">
-              <a:ln>
-                <a:noFill/>
-              </a:ln>
-              <a:solidFill>
-                <a:prstClr val="black"/>
-              </a:solidFill>
-              <a:effectLst/>
-              <a:uLnTx/>
-              <a:uFillTx/>
-              <a:latin typeface="Calibri" panose="020F0502020204030204"/>
-              <a:ea typeface="+mn-ea"/>
-              <a:cs typeface="Arial" panose="020B0604020202020204" pitchFamily="34" charset="0"/>
+              <a:t> des dermatoses bulleuses du sujet âgé</a:t>
+            </a:r>
+          </a:p>
+          <a:p>
+            <a:pPr marL="285750" indent="-285750" algn="l">
+              <a:spcBef>
+                <a:spcPts val="0"/>
+              </a:spcBef>
+              <a:spcAft>
+                <a:spcPts val="100"/>
+              </a:spcAft>
+              <a:buNone/>
+            </a:pPr>
+            <a:r>
+              <a:rPr lang="fr-FR" sz="1600" dirty="0">
+                <a:cs typeface="Arial" pitchFamily="34" charset="0"/>
+              </a:rPr>
+              <a:t>• Meilleur accès à l'</a:t>
+            </a:r>
+            <a:r>
+              <a:rPr lang="fr-FR" sz="1600" b="1" dirty="0" err="1">
+                <a:cs typeface="Arial" pitchFamily="34" charset="0"/>
+              </a:rPr>
+              <a:t>immunopathologie</a:t>
+            </a:r>
+            <a:endParaRPr lang="fr-FR" sz="1600" b="1" dirty="0">
+              <a:cs typeface="Arial" pitchFamily="34" charset="0"/>
             </a:endParaRPr>
+          </a:p>
+          <a:p>
+            <a:pPr marL="285750" indent="-285750" algn="l">
+              <a:spcBef>
+                <a:spcPts val="0"/>
+              </a:spcBef>
+              <a:spcAft>
+                <a:spcPts val="100"/>
+              </a:spcAft>
+              <a:buNone/>
+            </a:pPr>
+            <a:r>
+              <a:rPr lang="fr-FR" sz="1600" dirty="0">
+                <a:cs typeface="Arial" pitchFamily="34" charset="0"/>
+              </a:rPr>
+              <a:t>• Conduite d'une </a:t>
+            </a:r>
+            <a:r>
+              <a:rPr lang="fr-FR" sz="1600" b="1" dirty="0">
+                <a:cs typeface="Arial" pitchFamily="34" charset="0"/>
+              </a:rPr>
+              <a:t>étude prospective et multicentrique</a:t>
+            </a:r>
+            <a:r>
+              <a:rPr lang="fr-FR" sz="1600" dirty="0">
+                <a:cs typeface="Arial" pitchFamily="34" charset="0"/>
+              </a:rPr>
+              <a:t> pour consolider ces premières données béninoises</a:t>
+            </a:r>
           </a:p>
         </p:txBody>
       </p:sp>

</xml_diff>